<commit_message>
Revise CFR SOP after first-pass review
- Remove the Manning Institute reference (not accurate for the PBM
  Capital gift) pending the correct entity chain
- Fix a layout bug where the SOW callout could overlap/cut off the
  bottom of the decision-gate table on the one-pager
- Merge Development Officer and Health Development into a single
  stakeholder link (same fundraising function, different unit)
- Sharpen the OSP lesson learned: OSP held the only mechanism to
  disburse funds externally, since Gift/Advancement Accounting cannot
  send funds out
- Clarify the 5% Health Development fee should be negotiated as an
  addition on top of the gift, not a deduction from research funds

Co-Authored-By: Claude Sonnet 5 <noreply@anthropic.com>
Claude-Session: https://claude.ai/code/session_01RMSUFpvYZneMevaGAM4mgi
</commit_message>
<xml_diff>
--- a/docs/cfr-sop/Complex_Industry_Gift_Workflow_OnePager.pptx
+++ b/docs/cfr-sop/Complex_Industry_Gift_Workflow_OnePager.pptx
@@ -1006,7 +1006,7 @@
                 <a:ea typeface="Calibri" pitchFamily="34" charset="-122"/>
                 <a:cs typeface="Calibri" pitchFamily="34" charset="-120"/>
               </a:rPr>
-              <a:t>An 11-stage decision framework for evaluating, structuring, and stewarding industry-funded research gifts — validated by the PBM Capital / Manning Institute gift</a:t>
+              <a:t>An 11-stage decision framework for evaluating, structuring, and stewarding industry-funded research gifts — informed by the PBM Capital gift</a:t>
             </a:r>
             <a:endParaRPr lang="en-US" sz="900" dirty="0"/>
           </a:p>
@@ -1048,7 +1048,7 @@
                 <a:ea typeface="Calibri" pitchFamily="34" charset="-122"/>
                 <a:cs typeface="Calibri" pitchFamily="34" charset="-120"/>
               </a:rPr>
-              <a:t>v1.0 — Draft for Review</a:t>
+              <a:t>v0.2 — Draft for Review</a:t>
             </a:r>
             <a:endParaRPr lang="en-US" sz="950" dirty="0"/>
           </a:p>
@@ -1122,11 +1122,11 @@
         <p:spPr>
           <a:xfrm>
             <a:off x="411480" y="1261872"/>
-            <a:ext cx="1810969" cy="841248"/>
+            <a:ext cx="1810969" cy="731520"/>
           </a:xfrm>
           <a:prstGeom prst="roundRect">
             <a:avLst>
-              <a:gd name="adj" fmla="val 6522"/>
+              <a:gd name="adj" fmla="val 7500"/>
             </a:avLst>
           </a:prstGeom>
           <a:solidFill>
@@ -1148,8 +1148,8 @@
         </p:nvSpPr>
         <p:spPr>
           <a:xfrm>
-            <a:off x="493776" y="1344168"/>
-            <a:ext cx="1646377" cy="676656"/>
+            <a:off x="493776" y="1325880"/>
+            <a:ext cx="1646377" cy="603504"/>
           </a:xfrm>
           <a:prstGeom prst="rect">
             <a:avLst/>
@@ -1163,7 +1163,7 @@
           <a:p>
             <a:pPr indent="0" marL="0">
               <a:lnSpc>
-                <a:spcPct val="115000"/>
+                <a:spcPct val="110000"/>
               </a:lnSpc>
               <a:buNone/>
             </a:pPr>
@@ -1180,12 +1180,12 @@
             </a:r>
             <a:pPr indent="0" marL="0">
               <a:lnSpc>
-                <a:spcPct val="115000"/>
-              </a:lnSpc>
-              <a:buNone/>
-            </a:pPr>
-            <a:r>
-              <a:rPr lang="en-US" sz="1000" b="1" dirty="0">
+                <a:spcPct val="110000"/>
+              </a:lnSpc>
+              <a:buNone/>
+            </a:pPr>
+            <a:r>
+              <a:rPr lang="en-US" sz="950" b="1" dirty="0">
                 <a:solidFill>
                   <a:srgbClr val="232D4B"/>
                 </a:solidFill>
@@ -1200,12 +1200,12 @@
           <a:p>
             <a:pPr indent="0" marL="0">
               <a:lnSpc>
-                <a:spcPct val="115000"/>
-              </a:lnSpc>
-              <a:buNone/>
-            </a:pPr>
-            <a:r>
-              <a:rPr lang="en-US" sz="750" i="1" dirty="0">
+                <a:spcPct val="110000"/>
+              </a:lnSpc>
+              <a:buNone/>
+            </a:pPr>
+            <a:r>
+              <a:rPr lang="en-US" sz="730" i="1" dirty="0">
                 <a:solidFill>
                   <a:srgbClr val="5A6472"/>
                 </a:solidFill>
@@ -1228,11 +1228,11 @@
         <p:spPr>
           <a:xfrm>
             <a:off x="2323033" y="1261872"/>
-            <a:ext cx="1810969" cy="841248"/>
+            <a:ext cx="1810969" cy="731520"/>
           </a:xfrm>
           <a:prstGeom prst="roundRect">
             <a:avLst>
-              <a:gd name="adj" fmla="val 6522"/>
+              <a:gd name="adj" fmla="val 7500"/>
             </a:avLst>
           </a:prstGeom>
           <a:solidFill>
@@ -1254,8 +1254,8 @@
         </p:nvSpPr>
         <p:spPr>
           <a:xfrm>
-            <a:off x="2405329" y="1344168"/>
-            <a:ext cx="1646377" cy="676656"/>
+            <a:off x="2405329" y="1325880"/>
+            <a:ext cx="1646377" cy="603504"/>
           </a:xfrm>
           <a:prstGeom prst="rect">
             <a:avLst/>
@@ -1269,7 +1269,7 @@
           <a:p>
             <a:pPr indent="0" marL="0">
               <a:lnSpc>
-                <a:spcPct val="115000"/>
+                <a:spcPct val="110000"/>
               </a:lnSpc>
               <a:buNone/>
             </a:pPr>
@@ -1286,12 +1286,12 @@
             </a:r>
             <a:pPr indent="0" marL="0">
               <a:lnSpc>
-                <a:spcPct val="115000"/>
-              </a:lnSpc>
-              <a:buNone/>
-            </a:pPr>
-            <a:r>
-              <a:rPr lang="en-US" sz="1000" b="1" dirty="0">
+                <a:spcPct val="110000"/>
+              </a:lnSpc>
+              <a:buNone/>
+            </a:pPr>
+            <a:r>
+              <a:rPr lang="en-US" sz="950" b="1" dirty="0">
                 <a:solidFill>
                   <a:srgbClr val="FFFFFF"/>
                 </a:solidFill>
@@ -1306,12 +1306,12 @@
           <a:p>
             <a:pPr indent="0" marL="0">
               <a:lnSpc>
-                <a:spcPct val="115000"/>
-              </a:lnSpc>
-              <a:buNone/>
-            </a:pPr>
-            <a:r>
-              <a:rPr lang="en-US" sz="750" i="1" dirty="0">
+                <a:spcPct val="110000"/>
+              </a:lnSpc>
+              <a:buNone/>
+            </a:pPr>
+            <a:r>
+              <a:rPr lang="en-US" sz="730" i="1" dirty="0">
                 <a:solidFill>
                   <a:srgbClr val="FFF1E0"/>
                 </a:solidFill>
@@ -1334,11 +1334,11 @@
         <p:spPr>
           <a:xfrm>
             <a:off x="4234586" y="1261872"/>
-            <a:ext cx="1810969" cy="841248"/>
+            <a:ext cx="1810969" cy="731520"/>
           </a:xfrm>
           <a:prstGeom prst="roundRect">
             <a:avLst>
-              <a:gd name="adj" fmla="val 6522"/>
+              <a:gd name="adj" fmla="val 7500"/>
             </a:avLst>
           </a:prstGeom>
           <a:solidFill>
@@ -1360,8 +1360,8 @@
         </p:nvSpPr>
         <p:spPr>
           <a:xfrm>
-            <a:off x="4316882" y="1344168"/>
-            <a:ext cx="1646377" cy="676656"/>
+            <a:off x="4316882" y="1325880"/>
+            <a:ext cx="1646377" cy="603504"/>
           </a:xfrm>
           <a:prstGeom prst="rect">
             <a:avLst/>
@@ -1375,7 +1375,7 @@
           <a:p>
             <a:pPr indent="0" marL="0">
               <a:lnSpc>
-                <a:spcPct val="115000"/>
+                <a:spcPct val="110000"/>
               </a:lnSpc>
               <a:buNone/>
             </a:pPr>
@@ -1392,12 +1392,12 @@
             </a:r>
             <a:pPr indent="0" marL="0">
               <a:lnSpc>
-                <a:spcPct val="115000"/>
-              </a:lnSpc>
-              <a:buNone/>
-            </a:pPr>
-            <a:r>
-              <a:rPr lang="en-US" sz="1000" b="1" dirty="0">
+                <a:spcPct val="110000"/>
+              </a:lnSpc>
+              <a:buNone/>
+            </a:pPr>
+            <a:r>
+              <a:rPr lang="en-US" sz="950" b="1" dirty="0">
                 <a:solidFill>
                   <a:srgbClr val="232D4B"/>
                 </a:solidFill>
@@ -1412,12 +1412,12 @@
           <a:p>
             <a:pPr indent="0" marL="0">
               <a:lnSpc>
-                <a:spcPct val="115000"/>
-              </a:lnSpc>
-              <a:buNone/>
-            </a:pPr>
-            <a:r>
-              <a:rPr lang="en-US" sz="750" i="1" dirty="0">
+                <a:spcPct val="110000"/>
+              </a:lnSpc>
+              <a:buNone/>
+            </a:pPr>
+            <a:r>
+              <a:rPr lang="en-US" sz="730" i="1" dirty="0">
                 <a:solidFill>
                   <a:srgbClr val="5A6472"/>
                 </a:solidFill>
@@ -1440,11 +1440,11 @@
         <p:spPr>
           <a:xfrm>
             <a:off x="6146140" y="1261872"/>
-            <a:ext cx="1810969" cy="841248"/>
+            <a:ext cx="1810969" cy="731520"/>
           </a:xfrm>
           <a:prstGeom prst="roundRect">
             <a:avLst>
-              <a:gd name="adj" fmla="val 6522"/>
+              <a:gd name="adj" fmla="val 7500"/>
             </a:avLst>
           </a:prstGeom>
           <a:solidFill>
@@ -1466,8 +1466,8 @@
         </p:nvSpPr>
         <p:spPr>
           <a:xfrm>
-            <a:off x="6228436" y="1344168"/>
-            <a:ext cx="1646377" cy="676656"/>
+            <a:off x="6228436" y="1325880"/>
+            <a:ext cx="1646377" cy="603504"/>
           </a:xfrm>
           <a:prstGeom prst="rect">
             <a:avLst/>
@@ -1481,7 +1481,7 @@
           <a:p>
             <a:pPr indent="0" marL="0">
               <a:lnSpc>
-                <a:spcPct val="115000"/>
+                <a:spcPct val="110000"/>
               </a:lnSpc>
               <a:buNone/>
             </a:pPr>
@@ -1498,12 +1498,12 @@
             </a:r>
             <a:pPr indent="0" marL="0">
               <a:lnSpc>
-                <a:spcPct val="115000"/>
-              </a:lnSpc>
-              <a:buNone/>
-            </a:pPr>
-            <a:r>
-              <a:rPr lang="en-US" sz="1000" b="1" dirty="0">
+                <a:spcPct val="110000"/>
+              </a:lnSpc>
+              <a:buNone/>
+            </a:pPr>
+            <a:r>
+              <a:rPr lang="en-US" sz="950" b="1" dirty="0">
                 <a:solidFill>
                   <a:srgbClr val="FFFFFF"/>
                 </a:solidFill>
@@ -1518,12 +1518,12 @@
           <a:p>
             <a:pPr indent="0" marL="0">
               <a:lnSpc>
-                <a:spcPct val="115000"/>
-              </a:lnSpc>
-              <a:buNone/>
-            </a:pPr>
-            <a:r>
-              <a:rPr lang="en-US" sz="750" i="1" dirty="0">
+                <a:spcPct val="110000"/>
+              </a:lnSpc>
+              <a:buNone/>
+            </a:pPr>
+            <a:r>
+              <a:rPr lang="en-US" sz="730" i="1" dirty="0">
                 <a:solidFill>
                   <a:srgbClr val="FFF1E0"/>
                 </a:solidFill>
@@ -1546,11 +1546,11 @@
         <p:spPr>
           <a:xfrm>
             <a:off x="8057693" y="1261872"/>
-            <a:ext cx="1810969" cy="841248"/>
+            <a:ext cx="1810969" cy="731520"/>
           </a:xfrm>
           <a:prstGeom prst="roundRect">
             <a:avLst>
-              <a:gd name="adj" fmla="val 6522"/>
+              <a:gd name="adj" fmla="val 7500"/>
             </a:avLst>
           </a:prstGeom>
           <a:solidFill>
@@ -1572,8 +1572,8 @@
         </p:nvSpPr>
         <p:spPr>
           <a:xfrm>
-            <a:off x="8139989" y="1344168"/>
-            <a:ext cx="1646377" cy="676656"/>
+            <a:off x="8139989" y="1325880"/>
+            <a:ext cx="1646377" cy="603504"/>
           </a:xfrm>
           <a:prstGeom prst="rect">
             <a:avLst/>
@@ -1587,7 +1587,7 @@
           <a:p>
             <a:pPr indent="0" marL="0">
               <a:lnSpc>
-                <a:spcPct val="115000"/>
+                <a:spcPct val="110000"/>
               </a:lnSpc>
               <a:buNone/>
             </a:pPr>
@@ -1604,12 +1604,12 @@
             </a:r>
             <a:pPr indent="0" marL="0">
               <a:lnSpc>
-                <a:spcPct val="115000"/>
-              </a:lnSpc>
-              <a:buNone/>
-            </a:pPr>
-            <a:r>
-              <a:rPr lang="en-US" sz="1000" b="1" dirty="0">
+                <a:spcPct val="110000"/>
+              </a:lnSpc>
+              <a:buNone/>
+            </a:pPr>
+            <a:r>
+              <a:rPr lang="en-US" sz="950" b="1" dirty="0">
                 <a:solidFill>
                   <a:srgbClr val="232D4B"/>
                 </a:solidFill>
@@ -1624,12 +1624,12 @@
           <a:p>
             <a:pPr indent="0" marL="0">
               <a:lnSpc>
-                <a:spcPct val="115000"/>
-              </a:lnSpc>
-              <a:buNone/>
-            </a:pPr>
-            <a:r>
-              <a:rPr lang="en-US" sz="750" i="1" dirty="0">
+                <a:spcPct val="110000"/>
+              </a:lnSpc>
+              <a:buNone/>
+            </a:pPr>
+            <a:r>
+              <a:rPr lang="en-US" sz="730" i="1" dirty="0">
                 <a:solidFill>
                   <a:srgbClr val="5A6472"/>
                 </a:solidFill>
@@ -1652,11 +1652,11 @@
         <p:spPr>
           <a:xfrm>
             <a:off x="9969246" y="1261872"/>
-            <a:ext cx="1810969" cy="841248"/>
+            <a:ext cx="1810969" cy="731520"/>
           </a:xfrm>
           <a:prstGeom prst="roundRect">
             <a:avLst>
-              <a:gd name="adj" fmla="val 6522"/>
+              <a:gd name="adj" fmla="val 7500"/>
             </a:avLst>
           </a:prstGeom>
           <a:solidFill>
@@ -1678,8 +1678,8 @@
         </p:nvSpPr>
         <p:spPr>
           <a:xfrm>
-            <a:off x="10051542" y="1344168"/>
-            <a:ext cx="1646377" cy="676656"/>
+            <a:off x="10051542" y="1325880"/>
+            <a:ext cx="1646377" cy="603504"/>
           </a:xfrm>
           <a:prstGeom prst="rect">
             <a:avLst/>
@@ -1693,7 +1693,7 @@
           <a:p>
             <a:pPr indent="0" marL="0">
               <a:lnSpc>
-                <a:spcPct val="115000"/>
+                <a:spcPct val="110000"/>
               </a:lnSpc>
               <a:buNone/>
             </a:pPr>
@@ -1710,12 +1710,12 @@
             </a:r>
             <a:pPr indent="0" marL="0">
               <a:lnSpc>
-                <a:spcPct val="115000"/>
-              </a:lnSpc>
-              <a:buNone/>
-            </a:pPr>
-            <a:r>
-              <a:rPr lang="en-US" sz="1000" b="1" dirty="0">
+                <a:spcPct val="110000"/>
+              </a:lnSpc>
+              <a:buNone/>
+            </a:pPr>
+            <a:r>
+              <a:rPr lang="en-US" sz="950" b="1" dirty="0">
                 <a:solidFill>
                   <a:srgbClr val="232D4B"/>
                 </a:solidFill>
@@ -1730,12 +1730,12 @@
           <a:p>
             <a:pPr indent="0" marL="0">
               <a:lnSpc>
-                <a:spcPct val="115000"/>
-              </a:lnSpc>
-              <a:buNone/>
-            </a:pPr>
-            <a:r>
-              <a:rPr lang="en-US" sz="750" i="1" dirty="0">
+                <a:spcPct val="110000"/>
+              </a:lnSpc>
+              <a:buNone/>
+            </a:pPr>
+            <a:r>
+              <a:rPr lang="en-US" sz="730" i="1" dirty="0">
                 <a:solidFill>
                   <a:srgbClr val="5A6472"/>
                 </a:solidFill>
@@ -1757,12 +1757,12 @@
         </p:nvSpPr>
         <p:spPr>
           <a:xfrm>
-            <a:off x="2323033" y="2267712"/>
-            <a:ext cx="1810969" cy="841248"/>
+            <a:off x="2323033" y="2139696"/>
+            <a:ext cx="1810969" cy="731520"/>
           </a:xfrm>
           <a:prstGeom prst="roundRect">
             <a:avLst>
-              <a:gd name="adj" fmla="val 6522"/>
+              <a:gd name="adj" fmla="val 7500"/>
             </a:avLst>
           </a:prstGeom>
           <a:solidFill>
@@ -1784,8 +1784,8 @@
         </p:nvSpPr>
         <p:spPr>
           <a:xfrm>
-            <a:off x="2405329" y="2350008"/>
-            <a:ext cx="1646377" cy="676656"/>
+            <a:off x="2405329" y="2203704"/>
+            <a:ext cx="1646377" cy="603504"/>
           </a:xfrm>
           <a:prstGeom prst="rect">
             <a:avLst/>
@@ -1799,7 +1799,7 @@
           <a:p>
             <a:pPr indent="0" marL="0">
               <a:lnSpc>
-                <a:spcPct val="115000"/>
+                <a:spcPct val="110000"/>
               </a:lnSpc>
               <a:buNone/>
             </a:pPr>
@@ -1816,12 +1816,12 @@
             </a:r>
             <a:pPr indent="0" marL="0">
               <a:lnSpc>
-                <a:spcPct val="115000"/>
-              </a:lnSpc>
-              <a:buNone/>
-            </a:pPr>
-            <a:r>
-              <a:rPr lang="en-US" sz="1000" b="1" dirty="0">
+                <a:spcPct val="110000"/>
+              </a:lnSpc>
+              <a:buNone/>
+            </a:pPr>
+            <a:r>
+              <a:rPr lang="en-US" sz="950" b="1" dirty="0">
                 <a:solidFill>
                   <a:srgbClr val="232D4B"/>
                 </a:solidFill>
@@ -1836,12 +1836,12 @@
           <a:p>
             <a:pPr indent="0" marL="0">
               <a:lnSpc>
-                <a:spcPct val="115000"/>
-              </a:lnSpc>
-              <a:buNone/>
-            </a:pPr>
-            <a:r>
-              <a:rPr lang="en-US" sz="750" i="1" dirty="0">
+                <a:spcPct val="110000"/>
+              </a:lnSpc>
+              <a:buNone/>
+            </a:pPr>
+            <a:r>
+              <a:rPr lang="en-US" sz="730" i="1" dirty="0">
                 <a:solidFill>
                   <a:srgbClr val="5A6472"/>
                 </a:solidFill>
@@ -1863,12 +1863,12 @@
         </p:nvSpPr>
         <p:spPr>
           <a:xfrm>
-            <a:off x="4234586" y="2267712"/>
-            <a:ext cx="1810969" cy="841248"/>
+            <a:off x="4234586" y="2139696"/>
+            <a:ext cx="1810969" cy="731520"/>
           </a:xfrm>
           <a:prstGeom prst="roundRect">
             <a:avLst>
-              <a:gd name="adj" fmla="val 6522"/>
+              <a:gd name="adj" fmla="val 7500"/>
             </a:avLst>
           </a:prstGeom>
           <a:solidFill>
@@ -1890,8 +1890,8 @@
         </p:nvSpPr>
         <p:spPr>
           <a:xfrm>
-            <a:off x="4316882" y="2350008"/>
-            <a:ext cx="1646377" cy="676656"/>
+            <a:off x="4316882" y="2203704"/>
+            <a:ext cx="1646377" cy="603504"/>
           </a:xfrm>
           <a:prstGeom prst="rect">
             <a:avLst/>
@@ -1905,7 +1905,7 @@
           <a:p>
             <a:pPr indent="0" marL="0">
               <a:lnSpc>
-                <a:spcPct val="115000"/>
+                <a:spcPct val="110000"/>
               </a:lnSpc>
               <a:buNone/>
             </a:pPr>
@@ -1922,12 +1922,12 @@
             </a:r>
             <a:pPr indent="0" marL="0">
               <a:lnSpc>
-                <a:spcPct val="115000"/>
-              </a:lnSpc>
-              <a:buNone/>
-            </a:pPr>
-            <a:r>
-              <a:rPr lang="en-US" sz="1000" b="1" dirty="0">
+                <a:spcPct val="110000"/>
+              </a:lnSpc>
+              <a:buNone/>
+            </a:pPr>
+            <a:r>
+              <a:rPr lang="en-US" sz="950" b="1" dirty="0">
                 <a:solidFill>
                   <a:srgbClr val="232D4B"/>
                 </a:solidFill>
@@ -1942,12 +1942,12 @@
           <a:p>
             <a:pPr indent="0" marL="0">
               <a:lnSpc>
-                <a:spcPct val="115000"/>
-              </a:lnSpc>
-              <a:buNone/>
-            </a:pPr>
-            <a:r>
-              <a:rPr lang="en-US" sz="750" i="1" dirty="0">
+                <a:spcPct val="110000"/>
+              </a:lnSpc>
+              <a:buNone/>
+            </a:pPr>
+            <a:r>
+              <a:rPr lang="en-US" sz="730" i="1" dirty="0">
                 <a:solidFill>
                   <a:srgbClr val="5A6472"/>
                 </a:solidFill>
@@ -1969,12 +1969,12 @@
         </p:nvSpPr>
         <p:spPr>
           <a:xfrm>
-            <a:off x="6146140" y="2267712"/>
-            <a:ext cx="1810969" cy="841248"/>
+            <a:off x="6146140" y="2139696"/>
+            <a:ext cx="1810969" cy="731520"/>
           </a:xfrm>
           <a:prstGeom prst="roundRect">
             <a:avLst>
-              <a:gd name="adj" fmla="val 6522"/>
+              <a:gd name="adj" fmla="val 7500"/>
             </a:avLst>
           </a:prstGeom>
           <a:solidFill>
@@ -1996,8 +1996,8 @@
         </p:nvSpPr>
         <p:spPr>
           <a:xfrm>
-            <a:off x="6228436" y="2350008"/>
-            <a:ext cx="1646377" cy="676656"/>
+            <a:off x="6228436" y="2203704"/>
+            <a:ext cx="1646377" cy="603504"/>
           </a:xfrm>
           <a:prstGeom prst="rect">
             <a:avLst/>
@@ -2011,7 +2011,7 @@
           <a:p>
             <a:pPr indent="0" marL="0">
               <a:lnSpc>
-                <a:spcPct val="115000"/>
+                <a:spcPct val="110000"/>
               </a:lnSpc>
               <a:buNone/>
             </a:pPr>
@@ -2028,12 +2028,12 @@
             </a:r>
             <a:pPr indent="0" marL="0">
               <a:lnSpc>
-                <a:spcPct val="115000"/>
-              </a:lnSpc>
-              <a:buNone/>
-            </a:pPr>
-            <a:r>
-              <a:rPr lang="en-US" sz="1000" b="1" dirty="0">
+                <a:spcPct val="110000"/>
+              </a:lnSpc>
+              <a:buNone/>
+            </a:pPr>
+            <a:r>
+              <a:rPr lang="en-US" sz="950" b="1" dirty="0">
                 <a:solidFill>
                   <a:srgbClr val="232D4B"/>
                 </a:solidFill>
@@ -2048,12 +2048,12 @@
           <a:p>
             <a:pPr indent="0" marL="0">
               <a:lnSpc>
-                <a:spcPct val="115000"/>
-              </a:lnSpc>
-              <a:buNone/>
-            </a:pPr>
-            <a:r>
-              <a:rPr lang="en-US" sz="750" i="1" dirty="0">
+                <a:spcPct val="110000"/>
+              </a:lnSpc>
+              <a:buNone/>
+            </a:pPr>
+            <a:r>
+              <a:rPr lang="en-US" sz="730" i="1" dirty="0">
                 <a:solidFill>
                   <a:srgbClr val="5A6472"/>
                 </a:solidFill>
@@ -2075,12 +2075,12 @@
         </p:nvSpPr>
         <p:spPr>
           <a:xfrm>
-            <a:off x="8057693" y="2267712"/>
-            <a:ext cx="1810969" cy="841248"/>
+            <a:off x="8057693" y="2139696"/>
+            <a:ext cx="1810969" cy="731520"/>
           </a:xfrm>
           <a:prstGeom prst="roundRect">
             <a:avLst>
-              <a:gd name="adj" fmla="val 6522"/>
+              <a:gd name="adj" fmla="val 7500"/>
             </a:avLst>
           </a:prstGeom>
           <a:solidFill>
@@ -2102,8 +2102,8 @@
         </p:nvSpPr>
         <p:spPr>
           <a:xfrm>
-            <a:off x="8139989" y="2350008"/>
-            <a:ext cx="1646377" cy="676656"/>
+            <a:off x="8139989" y="2203704"/>
+            <a:ext cx="1646377" cy="603504"/>
           </a:xfrm>
           <a:prstGeom prst="rect">
             <a:avLst/>
@@ -2117,7 +2117,7 @@
           <a:p>
             <a:pPr indent="0" marL="0">
               <a:lnSpc>
-                <a:spcPct val="115000"/>
+                <a:spcPct val="110000"/>
               </a:lnSpc>
               <a:buNone/>
             </a:pPr>
@@ -2134,12 +2134,12 @@
             </a:r>
             <a:pPr indent="0" marL="0">
               <a:lnSpc>
-                <a:spcPct val="115000"/>
-              </a:lnSpc>
-              <a:buNone/>
-            </a:pPr>
-            <a:r>
-              <a:rPr lang="en-US" sz="1000" b="1" dirty="0">
+                <a:spcPct val="110000"/>
+              </a:lnSpc>
+              <a:buNone/>
+            </a:pPr>
+            <a:r>
+              <a:rPr lang="en-US" sz="950" b="1" dirty="0">
                 <a:solidFill>
                   <a:srgbClr val="232D4B"/>
                 </a:solidFill>
@@ -2154,12 +2154,12 @@
           <a:p>
             <a:pPr indent="0" marL="0">
               <a:lnSpc>
-                <a:spcPct val="115000"/>
-              </a:lnSpc>
-              <a:buNone/>
-            </a:pPr>
-            <a:r>
-              <a:rPr lang="en-US" sz="750" i="1" dirty="0">
+                <a:spcPct val="110000"/>
+              </a:lnSpc>
+              <a:buNone/>
+            </a:pPr>
+            <a:r>
+              <a:rPr lang="en-US" sz="730" i="1" dirty="0">
                 <a:solidFill>
                   <a:srgbClr val="5A6472"/>
                 </a:solidFill>
@@ -2181,12 +2181,12 @@
         </p:nvSpPr>
         <p:spPr>
           <a:xfrm>
-            <a:off x="9969246" y="2267712"/>
-            <a:ext cx="1810969" cy="841248"/>
+            <a:off x="9969246" y="2139696"/>
+            <a:ext cx="1810969" cy="731520"/>
           </a:xfrm>
           <a:prstGeom prst="roundRect">
             <a:avLst>
-              <a:gd name="adj" fmla="val 6522"/>
+              <a:gd name="adj" fmla="val 7500"/>
             </a:avLst>
           </a:prstGeom>
           <a:solidFill>
@@ -2208,8 +2208,8 @@
         </p:nvSpPr>
         <p:spPr>
           <a:xfrm>
-            <a:off x="10051542" y="2350008"/>
-            <a:ext cx="1646377" cy="676656"/>
+            <a:off x="10051542" y="2203704"/>
+            <a:ext cx="1646377" cy="603504"/>
           </a:xfrm>
           <a:prstGeom prst="rect">
             <a:avLst/>
@@ -2223,7 +2223,7 @@
           <a:p>
             <a:pPr indent="0" marL="0">
               <a:lnSpc>
-                <a:spcPct val="115000"/>
+                <a:spcPct val="110000"/>
               </a:lnSpc>
               <a:buNone/>
             </a:pPr>
@@ -2240,12 +2240,12 @@
             </a:r>
             <a:pPr indent="0" marL="0">
               <a:lnSpc>
-                <a:spcPct val="115000"/>
-              </a:lnSpc>
-              <a:buNone/>
-            </a:pPr>
-            <a:r>
-              <a:rPr lang="en-US" sz="1000" b="1" dirty="0">
+                <a:spcPct val="110000"/>
+              </a:lnSpc>
+              <a:buNone/>
+            </a:pPr>
+            <a:r>
+              <a:rPr lang="en-US" sz="950" b="1" dirty="0">
                 <a:solidFill>
                   <a:srgbClr val="232D4B"/>
                 </a:solidFill>
@@ -2260,12 +2260,12 @@
           <a:p>
             <a:pPr indent="0" marL="0">
               <a:lnSpc>
-                <a:spcPct val="115000"/>
-              </a:lnSpc>
-              <a:buNone/>
-            </a:pPr>
-            <a:r>
-              <a:rPr lang="en-US" sz="750" i="1" dirty="0">
+                <a:spcPct val="110000"/>
+              </a:lnSpc>
+              <a:buNone/>
+            </a:pPr>
+            <a:r>
+              <a:rPr lang="en-US" sz="730" i="1" dirty="0">
                 <a:solidFill>
                   <a:srgbClr val="5A6472"/>
                 </a:solidFill>
@@ -2326,7 +2326,7 @@
         </p:nvSpPr>
         <p:spPr>
           <a:xfrm>
-            <a:off x="1957273" y="2615184"/>
+            <a:off x="1957273" y="2432304"/>
             <a:ext cx="256032" cy="146304"/>
           </a:xfrm>
           <a:prstGeom prst="leftArrow">
@@ -2346,7 +2346,7 @@
         </p:nvSpPr>
         <p:spPr>
           <a:xfrm>
-            <a:off x="411480" y="3310128"/>
+            <a:off x="411480" y="3127248"/>
             <a:ext cx="3655466" cy="182880"/>
           </a:xfrm>
           <a:prstGeom prst="rect">
@@ -2392,7 +2392,7 @@
           </p:nvPr>
         </p:nvGraphicFramePr>
         <p:xfrm>
-          <a:off x="411480" y="3547872"/>
+          <a:off x="411480" y="3374136"/>
           <a:ext cx="3655466" cy="914400"/>
         </p:xfrm>
         <a:graphic>
@@ -2400,12 +2400,12 @@
             <a:tbl>
               <a:tblPr/>
               <a:tblGrid>
-                <a:gridCol w="1918106"/>
-                <a:gridCol w="457200"/>
-                <a:gridCol w="640080"/>
-                <a:gridCol w="640080"/>
+                <a:gridCol w="1680362"/>
+                <a:gridCol w="658368"/>
+                <a:gridCol w="658368"/>
+                <a:gridCol w="658368"/>
               </a:tblGrid>
-              <a:tr h="329184">
+              <a:tr h="219456">
                 <a:tc>
                   <a:txBody>
                     <a:bodyPr/>
@@ -2537,28 +2537,14 @@
                         <a:buNone/>
                       </a:pPr>
                       <a:r>
-                        <a:rPr lang="en-US" sz="750" b="1" dirty="0">
+                        <a:rPr lang="en-US" sz="800" b="1" dirty="0">
                           <a:solidFill>
                             <a:srgbClr val="FFFFFF"/>
                           </a:solidFill>
                         </a:rPr>
                         <a:t>Sponsored</a:t>
                       </a:r>
-                      <a:endParaRPr lang="en-US" sz="750" dirty="0"/>
-                    </a:p>
-                    <a:p>
-                      <a:pPr algn="ctr" indent="0" marL="0">
-                        <a:buNone/>
-                      </a:pPr>
-                      <a:r>
-                        <a:rPr lang="en-US" sz="750" b="1" dirty="0">
-                          <a:solidFill>
-                            <a:srgbClr val="FFFFFF"/>
-                          </a:solidFill>
-                        </a:rPr>
-                        <a:t>Research</a:t>
-                      </a:r>
-                      <a:endParaRPr lang="en-US" sz="750" dirty="0"/>
+                      <a:endParaRPr lang="en-US" sz="800" dirty="0"/>
                     </a:p>
                   </a:txBody>
                   <a:tcPr marL="91440" marR="91440" marT="45720" marB="45720" anchor="ctr">
@@ -2612,14 +2598,14 @@
                         <a:buNone/>
                       </a:pPr>
                       <a:r>
-                        <a:rPr lang="en-US" sz="750" b="1" dirty="0">
+                        <a:rPr lang="en-US" sz="800" b="1" dirty="0">
                           <a:solidFill>
                             <a:srgbClr val="FFFFFF"/>
                           </a:solidFill>
                         </a:rPr>
                         <a:t>Contract</a:t>
                       </a:r>
-                      <a:endParaRPr lang="en-US" sz="750" dirty="0"/>
+                      <a:endParaRPr lang="en-US" sz="800" dirty="0"/>
                     </a:p>
                   </a:txBody>
                   <a:tcPr marL="91440" marR="91440" marT="45720" marB="45720" anchor="ctr">
@@ -2665,7 +2651,7 @@
                   </a:tcPr>
                 </a:tc>
               </a:tr>
-              <a:tr h="201168">
+              <a:tr h="205740">
                 <a:tc>
                   <a:txBody>
                     <a:bodyPr/>
@@ -2675,14 +2661,14 @@
                         <a:buNone/>
                       </a:pPr>
                       <a:r>
-                        <a:rPr lang="en-US" sz="800" dirty="0">
+                        <a:rPr lang="en-US" sz="780" dirty="0">
                           <a:solidFill>
                             <a:srgbClr val="232D4B"/>
                           </a:solidFill>
                         </a:rPr>
                         <a:t>Unrestricted support</a:t>
                       </a:r>
-                      <a:endParaRPr lang="en-US" sz="800" dirty="0"/>
+                      <a:endParaRPr lang="en-US" sz="780" dirty="0"/>
                     </a:p>
                   </a:txBody>
                   <a:tcPr marL="91440" marR="91440" marT="45720" marB="45720" anchor="ctr">
@@ -2895,7 +2881,7 @@
                   </a:tcPr>
                 </a:tc>
               </a:tr>
-              <a:tr h="201168">
+              <a:tr h="205740">
                 <a:tc>
                   <a:txBody>
                     <a:bodyPr/>
@@ -2905,14 +2891,14 @@
                         <a:buNone/>
                       </a:pPr>
                       <a:r>
-                        <a:rPr lang="en-US" sz="800" dirty="0">
+                        <a:rPr lang="en-US" sz="780" dirty="0">
                           <a:solidFill>
                             <a:srgbClr val="232D4B"/>
                           </a:solidFill>
                         </a:rPr>
                         <a:t>Specific deliverables</a:t>
                       </a:r>
-                      <a:endParaRPr lang="en-US" sz="800" dirty="0"/>
+                      <a:endParaRPr lang="en-US" sz="780" dirty="0"/>
                     </a:p>
                   </a:txBody>
                   <a:tcPr marL="91440" marR="91440" marT="45720" marB="45720" anchor="ctr">
@@ -3133,7 +3119,7 @@
                   </a:tcPr>
                 </a:tc>
               </a:tr>
-              <a:tr h="201168">
+              <a:tr h="205740">
                 <a:tc>
                   <a:txBody>
                     <a:bodyPr/>
@@ -3143,14 +3129,14 @@
                         <a:buNone/>
                       </a:pPr>
                       <a:r>
-                        <a:rPr lang="en-US" sz="800" dirty="0">
+                        <a:rPr lang="en-US" sz="780" dirty="0">
                           <a:solidFill>
                             <a:srgbClr val="232D4B"/>
                           </a:solidFill>
                         </a:rPr>
                         <a:t>Publication restrictions</a:t>
                       </a:r>
-                      <a:endParaRPr lang="en-US" sz="800" dirty="0"/>
+                      <a:endParaRPr lang="en-US" sz="780" dirty="0"/>
                     </a:p>
                   </a:txBody>
                   <a:tcPr marL="91440" marR="91440" marT="45720" marB="45720" anchor="ctr">
@@ -3371,7 +3357,7 @@
                   </a:tcPr>
                 </a:tc>
               </a:tr>
-              <a:tr h="201168">
+              <a:tr h="205740">
                 <a:tc>
                   <a:txBody>
                     <a:bodyPr/>
@@ -3381,14 +3367,14 @@
                         <a:buNone/>
                       </a:pPr>
                       <a:r>
-                        <a:rPr lang="en-US" sz="800" dirty="0">
+                        <a:rPr lang="en-US" sz="780" dirty="0">
                           <a:solidFill>
                             <a:srgbClr val="232D4B"/>
                           </a:solidFill>
                         </a:rPr>
                         <a:t>IP expectations</a:t>
                       </a:r>
-                      <a:endParaRPr lang="en-US" sz="800" dirty="0"/>
+                      <a:endParaRPr lang="en-US" sz="780" dirty="0"/>
                     </a:p>
                   </a:txBody>
                   <a:tcPr marL="91440" marR="91440" marT="45720" marB="45720" anchor="ctr">
@@ -3609,7 +3595,7 @@
                   </a:tcPr>
                 </a:tc>
               </a:tr>
-              <a:tr h="201168">
+              <a:tr h="205740">
                 <a:tc>
                   <a:txBody>
                     <a:bodyPr/>
@@ -3619,14 +3605,14 @@
                         <a:buNone/>
                       </a:pPr>
                       <a:r>
-                        <a:rPr lang="en-US" sz="800" dirty="0">
+                        <a:rPr lang="en-US" sz="780" dirty="0">
                           <a:solidFill>
                             <a:srgbClr val="232D4B"/>
                           </a:solidFill>
                         </a:rPr>
                         <a:t>Donor directs research</a:t>
                       </a:r>
-                      <a:endParaRPr lang="en-US" sz="800" dirty="0"/>
+                      <a:endParaRPr lang="en-US" sz="780" dirty="0"/>
                     </a:p>
                   </a:txBody>
                   <a:tcPr marL="91440" marR="91440" marT="45720" marB="45720" anchor="ctr">
@@ -3847,7 +3833,7 @@
                   </a:tcPr>
                 </a:tc>
               </a:tr>
-              <a:tr h="201168">
+              <a:tr h="205740">
                 <a:tc>
                   <a:txBody>
                     <a:bodyPr/>
@@ -3857,14 +3843,14 @@
                         <a:buNone/>
                       </a:pPr>
                       <a:r>
-                        <a:rPr lang="en-US" sz="800" dirty="0">
+                        <a:rPr lang="en-US" sz="780" dirty="0">
                           <a:solidFill>
                             <a:srgbClr val="232D4B"/>
                           </a:solidFill>
                         </a:rPr>
                         <a:t>General stewardship only</a:t>
                       </a:r>
-                      <a:endParaRPr lang="en-US" sz="800" dirty="0"/>
+                      <a:endParaRPr lang="en-US" sz="780" dirty="0"/>
                     </a:p>
                   </a:txBody>
                   <a:tcPr marL="91440" marR="91440" marT="45720" marB="45720" anchor="ctr">
@@ -4089,12 +4075,12 @@
         </p:nvSpPr>
         <p:spPr>
           <a:xfrm>
-            <a:off x="411480" y="5175504"/>
-            <a:ext cx="3655466" cy="841248"/>
+            <a:off x="411480" y="5010912"/>
+            <a:ext cx="3655466" cy="1042416"/>
           </a:xfrm>
           <a:prstGeom prst="roundRect">
             <a:avLst>
-              <a:gd name="adj" fmla="val 5435"/>
+              <a:gd name="adj" fmla="val 4386"/>
             </a:avLst>
           </a:prstGeom>
           <a:solidFill>
@@ -4111,8 +4097,8 @@
         </p:nvSpPr>
         <p:spPr>
           <a:xfrm>
-            <a:off x="539496" y="5248656"/>
-            <a:ext cx="3399434" cy="694944"/>
+            <a:off x="539496" y="5074920"/>
+            <a:ext cx="3399434" cy="914400"/>
           </a:xfrm>
           <a:prstGeom prst="rect">
             <a:avLst/>
@@ -4126,15 +4112,15 @@
           <a:p>
             <a:pPr indent="0" marL="0">
               <a:lnSpc>
-                <a:spcPct val="110000"/>
+                <a:spcPct val="108000"/>
               </a:lnSpc>
               <a:spcAft>
-                <a:spcPts val="300"/>
+                <a:spcPts val="200"/>
               </a:spcAft>
               <a:buNone/>
             </a:pPr>
             <a:r>
-              <a:rPr lang="en-US" sz="800" b="1" dirty="0">
+              <a:rPr lang="en-US" sz="790" b="1" dirty="0">
                 <a:solidFill>
                   <a:srgbClr val="232D4B"/>
                 </a:solidFill>
@@ -4142,22 +4128,22 @@
                 <a:ea typeface="Calibri" pitchFamily="34" charset="-122"/>
                 <a:cs typeface="Calibri" pitchFamily="34" charset="-120"/>
               </a:rPr>
-              <a:t>SOW should include  </a:t>
-            </a:r>
-            <a:endParaRPr lang="en-US" sz="800" dirty="0"/>
-          </a:p>
-          <a:p>
-            <a:pPr indent="0" marL="0">
-              <a:lnSpc>
-                <a:spcPct val="110000"/>
+              <a:t>SOW should include:  </a:t>
+            </a:r>
+            <a:endParaRPr lang="en-US" sz="790" dirty="0"/>
+          </a:p>
+          <a:p>
+            <a:pPr indent="0" marL="0">
+              <a:lnSpc>
+                <a:spcPct val="108000"/>
               </a:lnSpc>
               <a:spcAft>
-                <a:spcPts val="300"/>
+                <a:spcPts val="200"/>
               </a:spcAft>
               <a:buNone/>
             </a:pPr>
             <a:r>
-              <a:rPr lang="en-US" sz="770" dirty="0">
+              <a:rPr lang="en-US" sz="760" dirty="0">
                 <a:solidFill>
                   <a:srgbClr val="5A6472"/>
                 </a:solidFill>
@@ -4167,20 +4153,20 @@
               </a:rPr>
               <a:t>Research objectives, themes, scope, faculty collaboration, general use of funds.</a:t>
             </a:r>
-            <a:endParaRPr lang="en-US" sz="800" dirty="0"/>
-          </a:p>
-          <a:p>
-            <a:pPr indent="0" marL="0">
-              <a:lnSpc>
-                <a:spcPct val="110000"/>
+            <a:endParaRPr lang="en-US" sz="790" dirty="0"/>
+          </a:p>
+          <a:p>
+            <a:pPr indent="0" marL="0">
+              <a:lnSpc>
+                <a:spcPct val="108000"/>
               </a:lnSpc>
               <a:spcAft>
-                <a:spcPts val="300"/>
+                <a:spcPts val="200"/>
               </a:spcAft>
               <a:buNone/>
             </a:pPr>
             <a:r>
-              <a:rPr lang="en-US" sz="800" b="1" dirty="0">
+              <a:rPr lang="en-US" sz="790" b="1" dirty="0">
                 <a:solidFill>
                   <a:srgbClr val="EF3F6B"/>
                 </a:solidFill>
@@ -4188,22 +4174,22 @@
                 <a:ea typeface="Calibri" pitchFamily="34" charset="-122"/>
                 <a:cs typeface="Calibri" pitchFamily="34" charset="-120"/>
               </a:rPr>
-              <a:t>SOW should avoid  </a:t>
-            </a:r>
-            <a:endParaRPr lang="en-US" sz="800" dirty="0"/>
-          </a:p>
-          <a:p>
-            <a:pPr indent="0" marL="0">
-              <a:lnSpc>
-                <a:spcPct val="110000"/>
+              <a:t>SOW should avoid:  </a:t>
+            </a:r>
+            <a:endParaRPr lang="en-US" sz="790" dirty="0"/>
+          </a:p>
+          <a:p>
+            <a:pPr indent="0" marL="0">
+              <a:lnSpc>
+                <a:spcPct val="108000"/>
               </a:lnSpc>
               <a:spcAft>
-                <a:spcPts val="300"/>
+                <a:spcPts val="200"/>
               </a:spcAft>
               <a:buNone/>
             </a:pPr>
             <a:r>
-              <a:rPr lang="en-US" sz="770" dirty="0">
+              <a:rPr lang="en-US" sz="760" dirty="0">
                 <a:solidFill>
                   <a:srgbClr val="5A6472"/>
                 </a:solidFill>
@@ -4213,7 +4199,7 @@
               </a:rPr>
               <a:t>Deliverables, milestones, deadlines, sponsor direction, publication requirements.</a:t>
             </a:r>
-            <a:endParaRPr lang="en-US" sz="800" dirty="0"/>
+            <a:endParaRPr lang="en-US" sz="790" dirty="0"/>
           </a:p>
         </p:txBody>
       </p:sp>
@@ -4225,7 +4211,7 @@
         </p:nvSpPr>
         <p:spPr>
           <a:xfrm>
-            <a:off x="4268114" y="3310128"/>
+            <a:off x="4268114" y="3127248"/>
             <a:ext cx="3655466" cy="182880"/>
           </a:xfrm>
           <a:prstGeom prst="rect">
@@ -4264,12 +4250,12 @@
         </p:nvSpPr>
         <p:spPr>
           <a:xfrm>
-            <a:off x="4268114" y="3547872"/>
-            <a:ext cx="3655466" cy="1051560"/>
+            <a:off x="4268114" y="3374136"/>
+            <a:ext cx="3655466" cy="1024128"/>
           </a:xfrm>
           <a:prstGeom prst="roundRect">
             <a:avLst>
-              <a:gd name="adj" fmla="val 4348"/>
+              <a:gd name="adj" fmla="val 4464"/>
             </a:avLst>
           </a:prstGeom>
           <a:solidFill>
@@ -4291,8 +4277,8 @@
         </p:nvSpPr>
         <p:spPr>
           <a:xfrm>
-            <a:off x="4396130" y="3630168"/>
-            <a:ext cx="1644853" cy="886968"/>
+            <a:off x="4396130" y="3456432"/>
+            <a:ext cx="1644853" cy="859536"/>
           </a:xfrm>
           <a:prstGeom prst="rect">
             <a:avLst/>
@@ -4306,12 +4292,12 @@
           <a:p>
             <a:pPr indent="0" marL="0">
               <a:lnSpc>
-                <a:spcPct val="135000"/>
-              </a:lnSpc>
-              <a:buNone/>
-            </a:pPr>
-            <a:r>
-              <a:rPr lang="en-US" sz="780" b="1" dirty="0">
+                <a:spcPct val="125000"/>
+              </a:lnSpc>
+              <a:buNone/>
+            </a:pPr>
+            <a:r>
+              <a:rPr lang="en-US" sz="760" b="1" dirty="0">
                 <a:solidFill>
                   <a:srgbClr val="232D4B"/>
                 </a:solidFill>
@@ -4321,17 +4307,17 @@
               </a:rPr>
               <a:t>1. Corporate Relations</a:t>
             </a:r>
-            <a:endParaRPr lang="en-US" sz="780" dirty="0"/>
-          </a:p>
-          <a:p>
-            <a:pPr indent="0" marL="0">
-              <a:lnSpc>
-                <a:spcPct val="135000"/>
-              </a:lnSpc>
-              <a:buNone/>
-            </a:pPr>
-            <a:r>
-              <a:rPr lang="en-US" sz="780" b="1" dirty="0">
+            <a:endParaRPr lang="en-US" sz="760" dirty="0"/>
+          </a:p>
+          <a:p>
+            <a:pPr indent="0" marL="0">
+              <a:lnSpc>
+                <a:spcPct val="125000"/>
+              </a:lnSpc>
+              <a:buNone/>
+            </a:pPr>
+            <a:r>
+              <a:rPr lang="en-US" sz="760" b="1" dirty="0">
                 <a:solidFill>
                   <a:srgbClr val="232D4B"/>
                 </a:solidFill>
@@ -4339,19 +4325,19 @@
                 <a:ea typeface="Calibri" pitchFamily="34" charset="-122"/>
                 <a:cs typeface="Calibri" pitchFamily="34" charset="-120"/>
               </a:rPr>
-              <a:t>2. Development Officer</a:t>
-            </a:r>
-            <a:endParaRPr lang="en-US" sz="780" dirty="0"/>
-          </a:p>
-          <a:p>
-            <a:pPr indent="0" marL="0">
-              <a:lnSpc>
-                <a:spcPct val="135000"/>
-              </a:lnSpc>
-              <a:buNone/>
-            </a:pPr>
-            <a:r>
-              <a:rPr lang="en-US" sz="780" b="1" dirty="0">
+              <a:t>2. Development Officer /</a:t>
+            </a:r>
+            <a:endParaRPr lang="en-US" sz="760" dirty="0"/>
+          </a:p>
+          <a:p>
+            <a:pPr indent="0" marL="0">
+              <a:lnSpc>
+                <a:spcPct val="125000"/>
+              </a:lnSpc>
+              <a:buNone/>
+            </a:pPr>
+            <a:r>
+              <a:rPr lang="en-US" sz="760" b="1" dirty="0">
                 <a:solidFill>
                   <a:srgbClr val="232D4B"/>
                 </a:solidFill>
@@ -4359,19 +4345,39 @@
                 <a:ea typeface="Calibri" pitchFamily="34" charset="-122"/>
                 <a:cs typeface="Calibri" pitchFamily="34" charset="-120"/>
               </a:rPr>
+              <a:t>    Health Development</a:t>
+            </a:r>
+            <a:endParaRPr lang="en-US" sz="760" dirty="0"/>
+          </a:p>
+          <a:p>
+            <a:pPr indent="0" marL="0">
+              <a:lnSpc>
+                <a:spcPct val="125000"/>
+              </a:lnSpc>
+              <a:buNone/>
+            </a:pPr>
+            <a:r>
+              <a:rPr lang="en-US" sz="760" b="1" dirty="0">
+                <a:solidFill>
+                  <a:srgbClr val="232D4B"/>
+                </a:solidFill>
+                <a:latin typeface="Calibri" pitchFamily="34" charset="0"/>
+                <a:ea typeface="Calibri" pitchFamily="34" charset="-122"/>
+                <a:cs typeface="Calibri" pitchFamily="34" charset="-120"/>
+              </a:rPr>
               <a:t>3. Dept. Leadership</a:t>
             </a:r>
-            <a:endParaRPr lang="en-US" sz="780" dirty="0"/>
-          </a:p>
-          <a:p>
-            <a:pPr indent="0" marL="0">
-              <a:lnSpc>
-                <a:spcPct val="135000"/>
-              </a:lnSpc>
-              <a:buNone/>
-            </a:pPr>
-            <a:r>
-              <a:rPr lang="en-US" sz="780" b="1" dirty="0">
+            <a:endParaRPr lang="en-US" sz="760" dirty="0"/>
+          </a:p>
+          <a:p>
+            <a:pPr indent="0" marL="0">
+              <a:lnSpc>
+                <a:spcPct val="125000"/>
+              </a:lnSpc>
+              <a:buNone/>
+            </a:pPr>
+            <a:r>
+              <a:rPr lang="en-US" sz="760" b="1" dirty="0">
                 <a:solidFill>
                   <a:srgbClr val="232D4B"/>
                 </a:solidFill>
@@ -4379,19 +4385,19 @@
                 <a:ea typeface="Calibri" pitchFamily="34" charset="-122"/>
                 <a:cs typeface="Calibri" pitchFamily="34" charset="-120"/>
               </a:rPr>
-              <a:t>4. Health Development*</a:t>
-            </a:r>
-            <a:endParaRPr lang="en-US" sz="780" dirty="0"/>
-          </a:p>
-          <a:p>
-            <a:pPr indent="0" marL="0">
-              <a:lnSpc>
-                <a:spcPct val="135000"/>
-              </a:lnSpc>
-              <a:buNone/>
-            </a:pPr>
-            <a:r>
-              <a:rPr lang="en-US" sz="780" b="1" dirty="0">
+              <a:t>4. Office of Sponsored</a:t>
+            </a:r>
+            <a:endParaRPr lang="en-US" sz="760" dirty="0"/>
+          </a:p>
+          <a:p>
+            <a:pPr indent="0" marL="0">
+              <a:lnSpc>
+                <a:spcPct val="125000"/>
+              </a:lnSpc>
+              <a:buNone/>
+            </a:pPr>
+            <a:r>
+              <a:rPr lang="en-US" sz="760" b="1" dirty="0">
                 <a:solidFill>
                   <a:srgbClr val="232D4B"/>
                 </a:solidFill>
@@ -4399,9 +4405,29 @@
                 <a:ea typeface="Calibri" pitchFamily="34" charset="-122"/>
                 <a:cs typeface="Calibri" pitchFamily="34" charset="-120"/>
               </a:rPr>
-              <a:t>5. Office of Sponsored Programs</a:t>
-            </a:r>
-            <a:endParaRPr lang="en-US" sz="780" dirty="0"/>
+              <a:t>    Programs</a:t>
+            </a:r>
+            <a:endParaRPr lang="en-US" sz="760" dirty="0"/>
+          </a:p>
+          <a:p>
+            <a:pPr indent="0" marL="0">
+              <a:lnSpc>
+                <a:spcPct val="125000"/>
+              </a:lnSpc>
+              <a:buNone/>
+            </a:pPr>
+            <a:r>
+              <a:rPr lang="en-US" sz="760" b="1" dirty="0">
+                <a:solidFill>
+                  <a:srgbClr val="232D4B"/>
+                </a:solidFill>
+                <a:latin typeface="Calibri" pitchFamily="34" charset="0"/>
+                <a:ea typeface="Calibri" pitchFamily="34" charset="-122"/>
+                <a:cs typeface="Calibri" pitchFamily="34" charset="-120"/>
+              </a:rPr>
+              <a:t>5. Gift Administration</a:t>
+            </a:r>
+            <a:endParaRPr lang="en-US" sz="760" dirty="0"/>
           </a:p>
         </p:txBody>
       </p:sp>
@@ -4413,8 +4439,8 @@
         </p:nvSpPr>
         <p:spPr>
           <a:xfrm>
-            <a:off x="6095848" y="3630168"/>
-            <a:ext cx="1644853" cy="886968"/>
+            <a:off x="6095848" y="3456432"/>
+            <a:ext cx="1644853" cy="859536"/>
           </a:xfrm>
           <a:prstGeom prst="rect">
             <a:avLst/>
@@ -4428,12 +4454,12 @@
           <a:p>
             <a:pPr indent="0" marL="0">
               <a:lnSpc>
-                <a:spcPct val="135000"/>
-              </a:lnSpc>
-              <a:buNone/>
-            </a:pPr>
-            <a:r>
-              <a:rPr lang="en-US" sz="780" b="1" dirty="0">
+                <a:spcPct val="125000"/>
+              </a:lnSpc>
+              <a:buNone/>
+            </a:pPr>
+            <a:r>
+              <a:rPr lang="en-US" sz="760" b="1" dirty="0">
                 <a:solidFill>
                   <a:srgbClr val="232D4B"/>
                 </a:solidFill>
@@ -4441,19 +4467,19 @@
                 <a:ea typeface="Calibri" pitchFamily="34" charset="-122"/>
                 <a:cs typeface="Calibri" pitchFamily="34" charset="-120"/>
               </a:rPr>
-              <a:t>6. Gift Administration</a:t>
-            </a:r>
-            <a:endParaRPr lang="en-US" sz="780" dirty="0"/>
-          </a:p>
-          <a:p>
-            <a:pPr indent="0" marL="0">
-              <a:lnSpc>
-                <a:spcPct val="135000"/>
-              </a:lnSpc>
-              <a:buNone/>
-            </a:pPr>
-            <a:r>
-              <a:rPr lang="en-US" sz="780" b="1" dirty="0">
+              <a:t>6. Finance</a:t>
+            </a:r>
+            <a:endParaRPr lang="en-US" sz="760" dirty="0"/>
+          </a:p>
+          <a:p>
+            <a:pPr indent="0" marL="0">
+              <a:lnSpc>
+                <a:spcPct val="125000"/>
+              </a:lnSpc>
+              <a:buNone/>
+            </a:pPr>
+            <a:r>
+              <a:rPr lang="en-US" sz="760" b="1" dirty="0">
                 <a:solidFill>
                   <a:srgbClr val="232D4B"/>
                 </a:solidFill>
@@ -4461,19 +4487,19 @@
                 <a:ea typeface="Calibri" pitchFamily="34" charset="-122"/>
                 <a:cs typeface="Calibri" pitchFamily="34" charset="-120"/>
               </a:rPr>
-              <a:t>7. Finance</a:t>
-            </a:r>
-            <a:endParaRPr lang="en-US" sz="780" dirty="0"/>
-          </a:p>
-          <a:p>
-            <a:pPr indent="0" marL="0">
-              <a:lnSpc>
-                <a:spcPct val="135000"/>
-              </a:lnSpc>
-              <a:buNone/>
-            </a:pPr>
-            <a:r>
-              <a:rPr lang="en-US" sz="780" b="1" dirty="0">
+              <a:t>7. Legal</a:t>
+            </a:r>
+            <a:endParaRPr lang="en-US" sz="760" dirty="0"/>
+          </a:p>
+          <a:p>
+            <a:pPr indent="0" marL="0">
+              <a:lnSpc>
+                <a:spcPct val="125000"/>
+              </a:lnSpc>
+              <a:buNone/>
+            </a:pPr>
+            <a:r>
+              <a:rPr lang="en-US" sz="760" b="1" dirty="0">
                 <a:solidFill>
                   <a:srgbClr val="232D4B"/>
                 </a:solidFill>
@@ -4481,19 +4507,19 @@
                 <a:ea typeface="Calibri" pitchFamily="34" charset="-122"/>
                 <a:cs typeface="Calibri" pitchFamily="34" charset="-120"/>
               </a:rPr>
-              <a:t>8. Legal</a:t>
-            </a:r>
-            <a:endParaRPr lang="en-US" sz="780" dirty="0"/>
-          </a:p>
-          <a:p>
-            <a:pPr indent="0" marL="0">
-              <a:lnSpc>
-                <a:spcPct val="135000"/>
-              </a:lnSpc>
-              <a:buNone/>
-            </a:pPr>
-            <a:r>
-              <a:rPr lang="en-US" sz="780" b="1" dirty="0">
+              <a:t>8. Research</a:t>
+            </a:r>
+            <a:endParaRPr lang="en-US" sz="760" dirty="0"/>
+          </a:p>
+          <a:p>
+            <a:pPr indent="0" marL="0">
+              <a:lnSpc>
+                <a:spcPct val="125000"/>
+              </a:lnSpc>
+              <a:buNone/>
+            </a:pPr>
+            <a:r>
+              <a:rPr lang="en-US" sz="760" b="1" dirty="0">
                 <a:solidFill>
                   <a:srgbClr val="232D4B"/>
                 </a:solidFill>
@@ -4501,19 +4527,19 @@
                 <a:ea typeface="Calibri" pitchFamily="34" charset="-122"/>
                 <a:cs typeface="Calibri" pitchFamily="34" charset="-120"/>
               </a:rPr>
-              <a:t>9. Research Administration</a:t>
-            </a:r>
-            <a:endParaRPr lang="en-US" sz="780" dirty="0"/>
-          </a:p>
-          <a:p>
-            <a:pPr indent="0" marL="0">
-              <a:lnSpc>
-                <a:spcPct val="135000"/>
-              </a:lnSpc>
-              <a:buNone/>
-            </a:pPr>
-            <a:r>
-              <a:rPr lang="en-US" sz="780" b="1" dirty="0">
+              <a:t>    Administration</a:t>
+            </a:r>
+            <a:endParaRPr lang="en-US" sz="760" dirty="0"/>
+          </a:p>
+          <a:p>
+            <a:pPr indent="0" marL="0">
+              <a:lnSpc>
+                <a:spcPct val="125000"/>
+              </a:lnSpc>
+              <a:buNone/>
+            </a:pPr>
+            <a:r>
+              <a:rPr lang="en-US" sz="760" b="1" dirty="0">
                 <a:solidFill>
                   <a:srgbClr val="232D4B"/>
                 </a:solidFill>
@@ -4521,9 +4547,29 @@
                 <a:ea typeface="Calibri" pitchFamily="34" charset="-122"/>
                 <a:cs typeface="Calibri" pitchFamily="34" charset="-120"/>
               </a:rPr>
-              <a:t>10. Collaborating Institution</a:t>
-            </a:r>
-            <a:endParaRPr lang="en-US" sz="780" dirty="0"/>
+              <a:t>9. Collaborating</a:t>
+            </a:r>
+            <a:endParaRPr lang="en-US" sz="760" dirty="0"/>
+          </a:p>
+          <a:p>
+            <a:pPr indent="0" marL="0">
+              <a:lnSpc>
+                <a:spcPct val="125000"/>
+              </a:lnSpc>
+              <a:buNone/>
+            </a:pPr>
+            <a:r>
+              <a:rPr lang="en-US" sz="760" b="1" dirty="0">
+                <a:solidFill>
+                  <a:srgbClr val="232D4B"/>
+                </a:solidFill>
+                <a:latin typeface="Calibri" pitchFamily="34" charset="0"/>
+                <a:ea typeface="Calibri" pitchFamily="34" charset="-122"/>
+                <a:cs typeface="Calibri" pitchFamily="34" charset="-120"/>
+              </a:rPr>
+              <a:t>    Institution</a:t>
+            </a:r>
+            <a:endParaRPr lang="en-US" sz="760" dirty="0"/>
           </a:p>
         </p:txBody>
       </p:sp>
@@ -4535,8 +4581,8 @@
         </p:nvSpPr>
         <p:spPr>
           <a:xfrm>
-            <a:off x="4268114" y="4626864"/>
-            <a:ext cx="3655466" cy="201168"/>
+            <a:off x="4268114" y="4434840"/>
+            <a:ext cx="3655466" cy="292608"/>
           </a:xfrm>
           <a:prstGeom prst="rect">
             <a:avLst/>
@@ -4549,6 +4595,9 @@
           <a:lstStyle/>
           <a:p>
             <a:pPr indent="0" marL="0">
+              <a:lnSpc>
+                <a:spcPct val="115000"/>
+              </a:lnSpc>
               <a:buNone/>
             </a:pPr>
             <a:r>
@@ -4560,7 +4609,7 @@
                 <a:ea typeface="Calibri" pitchFamily="34" charset="-122"/>
                 <a:cs typeface="Calibri" pitchFamily="34" charset="-120"/>
               </a:rPr>
-              <a:t>*if applicable — each link has an assigned owner: relationship, agreement, budget, compliance, accounting, or stewardship lead.</a:t>
+              <a:t>Development Officer / Health Development is one role in this chain — same function, central Advancement or the Health System. Each link also has an assigned owner: relationship, agreement, budget, compliance, accounting, or stewardship lead.</a:t>
             </a:r>
             <a:endParaRPr lang="en-US" sz="680" dirty="0"/>
           </a:p>
@@ -4574,12 +4623,12 @@
         </p:nvSpPr>
         <p:spPr>
           <a:xfrm>
-            <a:off x="4268114" y="4855464"/>
-            <a:ext cx="3655466" cy="1179576"/>
+            <a:off x="4268114" y="4745736"/>
+            <a:ext cx="3655466" cy="1307592"/>
           </a:xfrm>
           <a:prstGeom prst="roundRect">
             <a:avLst>
-              <a:gd name="adj" fmla="val 3876"/>
+              <a:gd name="adj" fmla="val 3497"/>
             </a:avLst>
           </a:prstGeom>
           <a:solidFill>
@@ -4601,7 +4650,7 @@
         </p:nvSpPr>
         <p:spPr>
           <a:xfrm>
-            <a:off x="4396130" y="4928616"/>
+            <a:off x="4396130" y="4818888"/>
             <a:ext cx="3399434" cy="164592"/>
           </a:xfrm>
           <a:prstGeom prst="rect">
@@ -4640,8 +4689,8 @@
         </p:nvSpPr>
         <p:spPr>
           <a:xfrm>
-            <a:off x="4396130" y="5111496"/>
-            <a:ext cx="3399434" cy="850392"/>
+            <a:off x="4396130" y="5001768"/>
+            <a:ext cx="3399434" cy="978408"/>
           </a:xfrm>
           <a:prstGeom prst="rect">
             <a:avLst/>
@@ -4655,12 +4704,12 @@
           <a:p>
             <a:pPr indent="0" marL="0">
               <a:lnSpc>
-                <a:spcPct val="125000"/>
-              </a:lnSpc>
-              <a:buNone/>
-            </a:pPr>
-            <a:r>
-              <a:rPr lang="en-US" sz="790" dirty="0">
+                <a:spcPct val="120000"/>
+              </a:lnSpc>
+              <a:buNone/>
+            </a:pPr>
+            <a:r>
+              <a:rPr lang="en-US" sz="770" dirty="0">
                 <a:solidFill>
                   <a:srgbClr val="232D4B"/>
                 </a:solidFill>
@@ -4670,7 +4719,7 @@
               </a:rPr>
               <a:t>Multiple institutions · Industry partner · International entity · Human subjects · Export controls · Intellectual property · Existing equity · Conflict of interest · Licensing · Technology transfer · Multiple funding entities · Pass-through funding</a:t>
             </a:r>
-            <a:endParaRPr lang="en-US" sz="790" dirty="0"/>
+            <a:endParaRPr lang="en-US" sz="770" dirty="0"/>
           </a:p>
         </p:txBody>
       </p:sp>
@@ -4682,7 +4731,7 @@
         </p:nvSpPr>
         <p:spPr>
           <a:xfrm>
-            <a:off x="8124749" y="3310128"/>
+            <a:off x="8124749" y="3127248"/>
             <a:ext cx="3655466" cy="182880"/>
           </a:xfrm>
           <a:prstGeom prst="rect">
@@ -4721,12 +4770,12 @@
         </p:nvSpPr>
         <p:spPr>
           <a:xfrm>
-            <a:off x="8124749" y="3547872"/>
-            <a:ext cx="3655466" cy="437083"/>
+            <a:off x="8124749" y="3374136"/>
+            <a:ext cx="3655466" cy="480974"/>
           </a:xfrm>
           <a:prstGeom prst="roundRect">
             <a:avLst>
-              <a:gd name="adj" fmla="val 8368"/>
+              <a:gd name="adj" fmla="val 7605"/>
             </a:avLst>
           </a:prstGeom>
           <a:solidFill>
@@ -4748,7 +4797,7 @@
         </p:nvSpPr>
         <p:spPr>
           <a:xfrm>
-            <a:off x="8207045" y="3725266"/>
+            <a:off x="8207045" y="3456432"/>
             <a:ext cx="82296" cy="82296"/>
           </a:xfrm>
           <a:prstGeom prst="oval">
@@ -4768,8 +4817,8 @@
         </p:nvSpPr>
         <p:spPr>
           <a:xfrm>
-            <a:off x="8362493" y="3575304"/>
-            <a:ext cx="3326282" cy="382219"/>
+            <a:off x="8362493" y="3392424"/>
+            <a:ext cx="3326282" cy="444398"/>
           </a:xfrm>
           <a:prstGeom prst="rect">
             <a:avLst/>
@@ -4783,12 +4832,12 @@
           <a:p>
             <a:pPr indent="0" marL="0">
               <a:lnSpc>
-                <a:spcPct val="108000"/>
-              </a:lnSpc>
-              <a:buNone/>
-            </a:pPr>
-            <a:r>
-              <a:rPr lang="en-US" sz="760" b="1" dirty="0">
+                <a:spcPct val="105000"/>
+              </a:lnSpc>
+              <a:buNone/>
+            </a:pPr>
+            <a:r>
+              <a:rPr lang="en-US" sz="710" b="1" dirty="0">
                 <a:solidFill>
                   <a:srgbClr val="232D4B"/>
                 </a:solidFill>
@@ -4798,17 +4847,17 @@
               </a:rPr>
               <a:t>Donor intent changed over time.</a:t>
             </a:r>
-            <a:endParaRPr lang="en-US" sz="760" dirty="0"/>
-          </a:p>
-          <a:p>
-            <a:pPr indent="0" marL="0">
-              <a:lnSpc>
-                <a:spcPct val="108000"/>
-              </a:lnSpc>
-              <a:buNone/>
-            </a:pPr>
-            <a:r>
-              <a:rPr lang="en-US" sz="760" dirty="0">
+            <a:endParaRPr lang="en-US" sz="710" dirty="0"/>
+          </a:p>
+          <a:p>
+            <a:pPr indent="0" marL="0">
+              <a:lnSpc>
+                <a:spcPct val="105000"/>
+              </a:lnSpc>
+              <a:buNone/>
+            </a:pPr>
+            <a:r>
+              <a:rPr lang="en-US" sz="710" dirty="0">
                 <a:solidFill>
                   <a:srgbClr val="5A6472"/>
                 </a:solidFill>
@@ -4818,7 +4867,7 @@
               </a:rPr>
               <a:t>→ Revisit donor motivation throughout the process.</a:t>
             </a:r>
-            <a:endParaRPr lang="en-US" sz="760" dirty="0"/>
+            <a:endParaRPr lang="en-US" sz="710" dirty="0"/>
           </a:p>
         </p:txBody>
       </p:sp>
@@ -4830,12 +4879,12 @@
         </p:nvSpPr>
         <p:spPr>
           <a:xfrm>
-            <a:off x="8124749" y="4048963"/>
-            <a:ext cx="3655466" cy="437083"/>
+            <a:off x="8124749" y="3909974"/>
+            <a:ext cx="3655466" cy="480974"/>
           </a:xfrm>
           <a:prstGeom prst="roundRect">
             <a:avLst>
-              <a:gd name="adj" fmla="val 8368"/>
+              <a:gd name="adj" fmla="val 7605"/>
             </a:avLst>
           </a:prstGeom>
           <a:solidFill>
@@ -4857,7 +4906,7 @@
         </p:nvSpPr>
         <p:spPr>
           <a:xfrm>
-            <a:off x="8207045" y="4226357"/>
+            <a:off x="8207045" y="3992270"/>
             <a:ext cx="82296" cy="82296"/>
           </a:xfrm>
           <a:prstGeom prst="oval">
@@ -4877,8 +4926,8 @@
         </p:nvSpPr>
         <p:spPr>
           <a:xfrm>
-            <a:off x="8362493" y="4076395"/>
-            <a:ext cx="3326282" cy="382219"/>
+            <a:off x="8362493" y="3928262"/>
+            <a:ext cx="3326282" cy="444398"/>
           </a:xfrm>
           <a:prstGeom prst="rect">
             <a:avLst/>
@@ -4892,12 +4941,12 @@
           <a:p>
             <a:pPr indent="0" marL="0">
               <a:lnSpc>
-                <a:spcPct val="108000"/>
-              </a:lnSpc>
-              <a:buNone/>
-            </a:pPr>
-            <a:r>
-              <a:rPr lang="en-US" sz="760" b="1" dirty="0">
+                <a:spcPct val="105000"/>
+              </a:lnSpc>
+              <a:buNone/>
+            </a:pPr>
+            <a:r>
+              <a:rPr lang="en-US" sz="710" b="1" dirty="0">
                 <a:solidFill>
                   <a:srgbClr val="232D4B"/>
                 </a:solidFill>
@@ -4905,19 +4954,19 @@
                 <a:ea typeface="Calibri" pitchFamily="34" charset="-122"/>
                 <a:cs typeface="Calibri" pitchFamily="34" charset="-120"/>
               </a:rPr>
-              <a:t>OSP became a critical partner.</a:t>
-            </a:r>
-            <a:endParaRPr lang="en-US" sz="760" dirty="0"/>
-          </a:p>
-          <a:p>
-            <a:pPr indent="0" marL="0">
-              <a:lnSpc>
-                <a:spcPct val="108000"/>
-              </a:lnSpc>
-              <a:buNone/>
-            </a:pPr>
-            <a:r>
-              <a:rPr lang="en-US" sz="760" dirty="0">
+              <a:t>OSP held the only mechanism to disburse funds externally.</a:t>
+            </a:r>
+            <a:endParaRPr lang="en-US" sz="710" dirty="0"/>
+          </a:p>
+          <a:p>
+            <a:pPr indent="0" marL="0">
+              <a:lnSpc>
+                <a:spcPct val="105000"/>
+              </a:lnSpc>
+              <a:buNone/>
+            </a:pPr>
+            <a:r>
+              <a:rPr lang="en-US" sz="710" dirty="0">
                 <a:solidFill>
                   <a:srgbClr val="5A6472"/>
                 </a:solidFill>
@@ -4925,9 +4974,9 @@
                 <a:ea typeface="Calibri" pitchFamily="34" charset="-122"/>
                 <a:cs typeface="Calibri" pitchFamily="34" charset="-120"/>
               </a:rPr>
-              <a:t>→ Engage OSP early for any research-related industry gift.</a:t>
-            </a:r>
-            <a:endParaRPr lang="en-US" sz="760" dirty="0"/>
+              <a:t>→ Engage OSP early — Advancement Accounting can't send funds out; OSP's payment channel often must.</a:t>
+            </a:r>
+            <a:endParaRPr lang="en-US" sz="710" dirty="0"/>
           </a:p>
         </p:txBody>
       </p:sp>
@@ -4939,12 +4988,12 @@
         </p:nvSpPr>
         <p:spPr>
           <a:xfrm>
-            <a:off x="8124749" y="4550054"/>
-            <a:ext cx="3655466" cy="437083"/>
+            <a:off x="8124749" y="4445813"/>
+            <a:ext cx="3655466" cy="480974"/>
           </a:xfrm>
           <a:prstGeom prst="roundRect">
             <a:avLst>
-              <a:gd name="adj" fmla="val 8368"/>
+              <a:gd name="adj" fmla="val 7605"/>
             </a:avLst>
           </a:prstGeom>
           <a:solidFill>
@@ -4966,7 +5015,7 @@
         </p:nvSpPr>
         <p:spPr>
           <a:xfrm>
-            <a:off x="8207045" y="4727448"/>
+            <a:off x="8207045" y="4528109"/>
             <a:ext cx="82296" cy="82296"/>
           </a:xfrm>
           <a:prstGeom prst="oval">
@@ -4986,8 +5035,8 @@
         </p:nvSpPr>
         <p:spPr>
           <a:xfrm>
-            <a:off x="8362493" y="4577486"/>
-            <a:ext cx="3326282" cy="382219"/>
+            <a:off x="8362493" y="4464101"/>
+            <a:ext cx="3326282" cy="444398"/>
           </a:xfrm>
           <a:prstGeom prst="rect">
             <a:avLst/>
@@ -5001,12 +5050,12 @@
           <a:p>
             <a:pPr indent="0" marL="0">
               <a:lnSpc>
-                <a:spcPct val="108000"/>
-              </a:lnSpc>
-              <a:buNone/>
-            </a:pPr>
-            <a:r>
-              <a:rPr lang="en-US" sz="760" b="1" dirty="0">
+                <a:spcPct val="105000"/>
+              </a:lnSpc>
+              <a:buNone/>
+            </a:pPr>
+            <a:r>
+              <a:rPr lang="en-US" sz="710" b="1" dirty="0">
                 <a:solidFill>
                   <a:srgbClr val="232D4B"/>
                 </a:solidFill>
@@ -5016,17 +5065,17 @@
               </a:rPr>
               <a:t>Multi-party gifts need special accounting.</a:t>
             </a:r>
-            <a:endParaRPr lang="en-US" sz="760" dirty="0"/>
-          </a:p>
-          <a:p>
-            <a:pPr indent="0" marL="0">
-              <a:lnSpc>
-                <a:spcPct val="108000"/>
-              </a:lnSpc>
-              <a:buNone/>
-            </a:pPr>
-            <a:r>
-              <a:rPr lang="en-US" sz="760" dirty="0">
+            <a:endParaRPr lang="en-US" sz="710" dirty="0"/>
+          </a:p>
+          <a:p>
+            <a:pPr indent="0" marL="0">
+              <a:lnSpc>
+                <a:spcPct val="105000"/>
+              </a:lnSpc>
+              <a:buNone/>
+            </a:pPr>
+            <a:r>
+              <a:rPr lang="en-US" sz="710" dirty="0">
                 <a:solidFill>
                   <a:srgbClr val="5A6472"/>
                 </a:solidFill>
@@ -5036,7 +5085,7 @@
               </a:rPr>
               <a:t>→ Involve Gift Administration before agreements are finalized.</a:t>
             </a:r>
-            <a:endParaRPr lang="en-US" sz="760" dirty="0"/>
+            <a:endParaRPr lang="en-US" sz="710" dirty="0"/>
           </a:p>
         </p:txBody>
       </p:sp>
@@ -5048,12 +5097,12 @@
         </p:nvSpPr>
         <p:spPr>
           <a:xfrm>
-            <a:off x="8124749" y="5051146"/>
-            <a:ext cx="3655466" cy="437083"/>
+            <a:off x="8124749" y="4981651"/>
+            <a:ext cx="3655466" cy="480974"/>
           </a:xfrm>
           <a:prstGeom prst="roundRect">
             <a:avLst>
-              <a:gd name="adj" fmla="val 8368"/>
+              <a:gd name="adj" fmla="val 7605"/>
             </a:avLst>
           </a:prstGeom>
           <a:solidFill>
@@ -5075,7 +5124,7 @@
         </p:nvSpPr>
         <p:spPr>
           <a:xfrm>
-            <a:off x="8207045" y="5228539"/>
+            <a:off x="8207045" y="5063947"/>
             <a:ext cx="82296" cy="82296"/>
           </a:xfrm>
           <a:prstGeom prst="oval">
@@ -5095,8 +5144,8 @@
         </p:nvSpPr>
         <p:spPr>
           <a:xfrm>
-            <a:off x="8362493" y="5078578"/>
-            <a:ext cx="3326282" cy="382219"/>
+            <a:off x="8362493" y="4999939"/>
+            <a:ext cx="3326282" cy="444398"/>
           </a:xfrm>
           <a:prstGeom prst="rect">
             <a:avLst/>
@@ -5110,12 +5159,12 @@
           <a:p>
             <a:pPr indent="0" marL="0">
               <a:lnSpc>
-                <a:spcPct val="108000"/>
-              </a:lnSpc>
-              <a:buNone/>
-            </a:pPr>
-            <a:r>
-              <a:rPr lang="en-US" sz="760" b="1" dirty="0">
+                <a:spcPct val="105000"/>
+              </a:lnSpc>
+              <a:buNone/>
+            </a:pPr>
+            <a:r>
+              <a:rPr lang="en-US" sz="710" b="1" dirty="0">
                 <a:solidFill>
                   <a:srgbClr val="232D4B"/>
                 </a:solidFill>
@@ -5123,19 +5172,19 @@
                 <a:ea typeface="Calibri" pitchFamily="34" charset="-122"/>
                 <a:cs typeface="Calibri" pitchFamily="34" charset="-120"/>
               </a:rPr>
-              <a:t>The 5% Health Dev. fee reduced research funds.</a:t>
-            </a:r>
-            <a:endParaRPr lang="en-US" sz="760" dirty="0"/>
-          </a:p>
-          <a:p>
-            <a:pPr indent="0" marL="0">
-              <a:lnSpc>
-                <a:spcPct val="108000"/>
-              </a:lnSpc>
-              <a:buNone/>
-            </a:pPr>
-            <a:r>
-              <a:rPr lang="en-US" sz="760" dirty="0">
+              <a:t>The 5% Health Dev. fee can reduce research funds if unaddressed.</a:t>
+            </a:r>
+            <a:endParaRPr lang="en-US" sz="710" dirty="0"/>
+          </a:p>
+          <a:p>
+            <a:pPr indent="0" marL="0">
+              <a:lnSpc>
+                <a:spcPct val="105000"/>
+              </a:lnSpc>
+              <a:buNone/>
+            </a:pPr>
+            <a:r>
+              <a:rPr lang="en-US" sz="710" dirty="0">
                 <a:solidFill>
                   <a:srgbClr val="5A6472"/>
                 </a:solidFill>
@@ -5143,9 +5192,9 @@
                 <a:ea typeface="Calibri" pitchFamily="34" charset="-122"/>
                 <a:cs typeface="Calibri" pitchFamily="34" charset="-120"/>
               </a:rPr>
-              <a:t>→ Discuss fee treatment early; consider a separate unrestricted gift.</a:t>
-            </a:r>
-            <a:endParaRPr lang="en-US" sz="760" dirty="0"/>
+              <a:t>→ Negotiate the fee on top of the gift, discussed with the donor upfront.</a:t>
+            </a:r>
+            <a:endParaRPr lang="en-US" sz="710" dirty="0"/>
           </a:p>
         </p:txBody>
       </p:sp>
@@ -5157,12 +5206,12 @@
         </p:nvSpPr>
         <p:spPr>
           <a:xfrm>
-            <a:off x="8124749" y="5552237"/>
-            <a:ext cx="3655466" cy="437083"/>
+            <a:off x="8124749" y="5517490"/>
+            <a:ext cx="3655466" cy="480974"/>
           </a:xfrm>
           <a:prstGeom prst="roundRect">
             <a:avLst>
-              <a:gd name="adj" fmla="val 8368"/>
+              <a:gd name="adj" fmla="val 7605"/>
             </a:avLst>
           </a:prstGeom>
           <a:solidFill>
@@ -5184,7 +5233,7 @@
         </p:nvSpPr>
         <p:spPr>
           <a:xfrm>
-            <a:off x="8207045" y="5729630"/>
+            <a:off x="8207045" y="5599786"/>
             <a:ext cx="82296" cy="82296"/>
           </a:xfrm>
           <a:prstGeom prst="oval">
@@ -5204,8 +5253,8 @@
         </p:nvSpPr>
         <p:spPr>
           <a:xfrm>
-            <a:off x="8362493" y="5579669"/>
-            <a:ext cx="3326282" cy="382219"/>
+            <a:off x="8362493" y="5535778"/>
+            <a:ext cx="3326282" cy="444398"/>
           </a:xfrm>
           <a:prstGeom prst="rect">
             <a:avLst/>
@@ -5219,12 +5268,12 @@
           <a:p>
             <a:pPr indent="0" marL="0">
               <a:lnSpc>
-                <a:spcPct val="108000"/>
-              </a:lnSpc>
-              <a:buNone/>
-            </a:pPr>
-            <a:r>
-              <a:rPr lang="en-US" sz="760" b="1" dirty="0">
+                <a:spcPct val="105000"/>
+              </a:lnSpc>
+              <a:buNone/>
+            </a:pPr>
+            <a:r>
+              <a:rPr lang="en-US" sz="710" b="1" dirty="0">
                 <a:solidFill>
                   <a:srgbClr val="232D4B"/>
                 </a:solidFill>
@@ -5234,17 +5283,17 @@
               </a:rPr>
               <a:t>Many offices touched the project.</a:t>
             </a:r>
-            <a:endParaRPr lang="en-US" sz="760" dirty="0"/>
-          </a:p>
-          <a:p>
-            <a:pPr indent="0" marL="0">
-              <a:lnSpc>
-                <a:spcPct val="108000"/>
-              </a:lnSpc>
-              <a:buNone/>
-            </a:pPr>
-            <a:r>
-              <a:rPr lang="en-US" sz="760" dirty="0">
+            <a:endParaRPr lang="en-US" sz="710" dirty="0"/>
+          </a:p>
+          <a:p>
+            <a:pPr indent="0" marL="0">
+              <a:lnSpc>
+                <a:spcPct val="105000"/>
+              </a:lnSpc>
+              <a:buNone/>
+            </a:pPr>
+            <a:r>
+              <a:rPr lang="en-US" sz="710" dirty="0">
                 <a:solidFill>
                   <a:srgbClr val="5A6472"/>
                 </a:solidFill>
@@ -5254,7 +5303,7 @@
               </a:rPr>
               <a:t>→ Assign one CFR lead to quarterback the donor experience.</a:t>
             </a:r>
-            <a:endParaRPr lang="en-US" sz="760" dirty="0"/>
+            <a:endParaRPr lang="en-US" sz="710" dirty="0"/>
           </a:p>
         </p:txBody>
       </p:sp>

</xml_diff>